<commit_message>
docs(artigo): formaliza "Questões em aberto" (gaps) no doc e na apresentação
- §7 (Conclusão) ganha subseção "Questões em aberto": 5 questões que delimitam
  os gaps (causalidade do onboarding, navegação/clareza, extração+qualidade
  MPO, generalização, queda de governança). Espelhado no docx SBC e no markdown.
- Apresentação: novo slide "Questões em aberto" (4 frentes: onboarding,
  navegação guiada, extração e qualidade, escala e governança); páginas
  renumeradas para /12.

Co-Authored-By: Claude Opus 4.8 <noreply@anthropic.com>
</commit_message>
<xml_diff>
--- a/atividades/apresentacoes/validacao_mvp_comparativo.pptx
+++ b/atividades/apresentacoes/validacao_mvp_comparativo.pptx
@@ -17,6 +17,7 @@
     <p:sldId id="262" r:id="rId8"/>
     <p:sldId id="263" r:id="rId9"/>
     <p:sldId id="264" r:id="rId10"/>
+    <p:sldId id="267" r:id="rId18"/>
     <p:sldId id="265" r:id="rId11"/>
     <p:sldId id="266" r:id="rId12"/>
   </p:sldIdLst>
@@ -1532,6 +1533,10 @@
             <a:prstDash val="solid"/>
           </a:ln>
         </p:spPr>
+        <p:txBody>
+          <a:bodyPr/>
+          <a:p/>
+        </p:txBody>
       </p:sp>
       <p:pic>
         <p:nvPicPr>
@@ -1699,6 +1704,10 @@
             <a:prstDash val="solid"/>
           </a:ln>
         </p:spPr>
+        <p:txBody>
+          <a:bodyPr/>
+          <a:p/>
+        </p:txBody>
       </p:sp>
       <p:sp>
         <p:nvSpPr>
@@ -1980,6 +1989,10 @@
             <a:prstDash val="solid"/>
           </a:ln>
         </p:spPr>
+        <p:txBody>
+          <a:bodyPr/>
+          <a:p/>
+        </p:txBody>
       </p:sp>
       <p:pic>
         <p:nvPicPr>
@@ -2142,7 +2155,7 @@
                   <a:srgbClr val="5A5F6A"/>
                 </a:solidFill>
               </a:rPr>
-              <a:t>10 / 11</a:t>
+              <a:t>11 / 12</a:t>
             </a:r>
             <a:endParaRPr lang="en-US" sz="850" dirty="0"/>
           </a:p>
@@ -2223,6 +2236,10 @@
             <a:prstDash val="solid"/>
           </a:ln>
         </p:spPr>
+        <p:txBody>
+          <a:bodyPr/>
+          <a:p/>
+        </p:txBody>
       </p:sp>
       <p:sp>
         <p:nvSpPr>
@@ -2350,6 +2367,10 @@
             <a:prstDash val="solid"/>
           </a:ln>
         </p:spPr>
+        <p:txBody>
+          <a:bodyPr/>
+          <a:p/>
+        </p:txBody>
       </p:sp>
       <p:pic>
         <p:nvPicPr>
@@ -2435,6 +2456,10 @@
             <a:prstDash val="solid"/>
           </a:ln>
         </p:spPr>
+        <p:txBody>
+          <a:bodyPr/>
+          <a:p/>
+        </p:txBody>
       </p:sp>
       <p:sp>
         <p:nvSpPr>
@@ -2524,6 +2549,874 @@
           </a:p>
         </p:txBody>
       </p:sp>
+    </p:spTree>
+  </p:cSld>
+  <p:clrMapOvr>
+    <a:masterClrMapping/>
+  </p:clrMapOvr>
+</p:sld>
+</file>
+
+<file path=ppt/slides/slide12.xml><?xml version="1.0" encoding="utf-8"?>
+<p:sld xmlns:a="http://schemas.openxmlformats.org/drawingml/2006/main" xmlns:p="http://schemas.openxmlformats.org/presentationml/2006/main" xmlns:r="http://schemas.openxmlformats.org/officeDocument/2006/relationships">
+  <p:cSld>
+    <p:bg>
+      <p:bgPr>
+        <a:solidFill>
+          <a:srgbClr val="FFFFFF"/>
+        </a:solidFill>
+        <a:effectLst/>
+      </p:bgPr>
+    </p:bg>
+    <p:spTree>
+      <p:nvGrpSpPr>
+        <p:cNvPr id="1" name=""/>
+        <p:cNvGrpSpPr/>
+        <p:nvPr/>
+      </p:nvGrpSpPr>
+      <p:grpSpPr/>
+      <p:sp>
+        <p:nvSpPr>
+          <p:cNvPr id="28" name="Shape 7">
+            <a:extLst>
+              <a:ext uri="{FF2B5EF4-FFF2-40B4-BE49-F238E27FC236}">
+                <a16:creationId xmlns:a16="http://schemas.microsoft.com/office/drawing/2014/main" id="{E4281F19-DED5-C561-43E6-D93F25F40BE4}"/>
+              </a:ext>
+            </a:extLst>
+          </p:cNvPr>
+          <p:cNvSpPr/>
+          <p:nvPr/>
+        </p:nvSpPr>
+        <p:spPr>
+          <a:xfrm>
+            <a:off x="822960" y="5026871"/>
+            <a:ext cx="9235440" cy="868680"/>
+          </a:xfrm>
+          <a:prstGeom prst="rect">
+            <a:avLst/>
+          </a:prstGeom>
+          <a:solidFill>
+            <a:srgbClr val="F3F5F8"/>
+          </a:solidFill>
+          <a:ln w="12700">
+            <a:solidFill>
+              <a:srgbClr val="E5E7EB"/>
+            </a:solidFill>
+            <a:prstDash val="solid"/>
+          </a:ln>
+        </p:spPr>
+        <p:txBody>
+          <a:bodyPr/>
+          <a:p/>
+        </p:txBody>
+      </p:sp>
+      <p:sp>
+        <p:nvSpPr>
+          <p:cNvPr id="2" name="Text 0"/>
+          <p:cNvSpPr/>
+          <p:nvPr/>
+        </p:nvSpPr>
+        <p:spPr>
+          <a:xfrm>
+            <a:off x="457200" y="420624"/>
+            <a:ext cx="4846320" cy="274320"/>
+          </a:xfrm>
+          <a:prstGeom prst="rect">
+            <a:avLst/>
+          </a:prstGeom>
+          <a:noFill/>
+          <a:ln/>
+        </p:spPr>
+        <p:txBody>
+          <a:bodyPr wrap="square" lIns="0" tIns="0" rIns="0" bIns="0" rtlCol="0" anchor="ctr"/>
+          <a:lstStyle/>
+          <a:p>
+            <a:pPr marL="0" indent="0">
+              <a:buNone/>
+            </a:pPr>
+            <a:r>
+              <a:rPr lang="en-US" sz="1000" b="1" dirty="0">
+                <a:solidFill>
+                  <a:srgbClr val="E52529"/>
+                </a:solidFill>
+                <a:latin typeface="Arial" pitchFamily="34" charset="0"/>
+                <a:ea typeface="Arial" pitchFamily="34" charset="-122"/>
+                <a:cs typeface="Arial" pitchFamily="34" charset="-120"/>
+              </a:rPr>
+              <a:t>QUESTÕES EM ABERTO</a:t>
+            </a:r>
+            <a:endParaRPr lang="en-US" sz="1000" dirty="0"/>
+          </a:p>
+        </p:txBody>
+      </p:sp>
+      <p:sp>
+        <p:nvSpPr>
+          <p:cNvPr id="3" name="Shape 1"/>
+          <p:cNvSpPr/>
+          <p:nvPr/>
+        </p:nvSpPr>
+        <p:spPr>
+          <a:xfrm>
+            <a:off x="457200" y="749808"/>
+            <a:ext cx="868680" cy="32004"/>
+          </a:xfrm>
+          <a:prstGeom prst="rect">
+            <a:avLst/>
+          </a:prstGeom>
+          <a:solidFill>
+            <a:srgbClr val="E52529"/>
+          </a:solidFill>
+          <a:ln w="12700">
+            <a:solidFill>
+              <a:srgbClr val="E52529"/>
+            </a:solidFill>
+            <a:prstDash val="solid"/>
+          </a:ln>
+        </p:spPr>
+        <p:txBody>
+          <a:bodyPr/>
+          <a:p/>
+        </p:txBody>
+      </p:sp>
+      <p:sp>
+        <p:nvSpPr>
+          <p:cNvPr id="5" name="Text 2"/>
+          <p:cNvSpPr/>
+          <p:nvPr/>
+        </p:nvSpPr>
+        <p:spPr>
+          <a:xfrm>
+            <a:off x="457200" y="6473952"/>
+            <a:ext cx="5669280" cy="201168"/>
+          </a:xfrm>
+          <a:prstGeom prst="rect">
+            <a:avLst/>
+          </a:prstGeom>
+          <a:noFill/>
+          <a:ln/>
+        </p:spPr>
+        <p:txBody>
+          <a:bodyPr wrap="square" lIns="0" tIns="0" rIns="0" bIns="0" rtlCol="0" anchor="ctr"/>
+          <a:lstStyle/>
+          <a:p>
+            <a:pPr marL="0" indent="0">
+              <a:buNone/>
+            </a:pPr>
+            <a:r>
+              <a:rPr lang="en-US" sz="850" dirty="0">
+                <a:solidFill>
+                  <a:srgbClr val="5A5F6A"/>
+                </a:solidFill>
+              </a:rPr>
+              <a:t>Equipe ObiOne · Doutorado PPGEC · UPE/POLI · Junho 2026</a:t>
+            </a:r>
+            <a:endParaRPr lang="en-US" sz="850" dirty="0"/>
+          </a:p>
+        </p:txBody>
+      </p:sp>
+      <p:sp>
+        <p:nvSpPr>
+          <p:cNvPr id="6" name="Text 3"/>
+          <p:cNvSpPr/>
+          <p:nvPr/>
+        </p:nvSpPr>
+        <p:spPr>
+          <a:xfrm>
+            <a:off x="502920" y="932688"/>
+            <a:ext cx="9875520" cy="594360"/>
+          </a:xfrm>
+          <a:prstGeom prst="rect">
+            <a:avLst/>
+          </a:prstGeom>
+          <a:noFill/>
+          <a:ln/>
+        </p:spPr>
+        <p:txBody>
+          <a:bodyPr wrap="square" lIns="0" tIns="0" rIns="0" bIns="0" rtlCol="0" anchor="ctr">
+            <a:normAutofit/>
+          </a:bodyPr>
+          <a:lstStyle/>
+          <a:p>
+            <a:pPr marL="0" indent="0">
+              <a:buNone/>
+            </a:pPr>
+            <a:r>
+              <a:t>Questões em aberto para fechar os gaps da pesquisa</a:t>
+            </a:r>
+            <a:endParaRPr lang="en-US" sz="3000" dirty="0"/>
+          </a:p>
+        </p:txBody>
+      </p:sp>
+      <p:sp>
+        <p:nvSpPr>
+          <p:cNvPr id="7" name="Text 4"/>
+          <p:cNvSpPr/>
+          <p:nvPr/>
+        </p:nvSpPr>
+        <p:spPr>
+          <a:xfrm>
+            <a:off x="521208" y="1572768"/>
+            <a:ext cx="9875520" cy="320040"/>
+          </a:xfrm>
+          <a:prstGeom prst="rect">
+            <a:avLst/>
+          </a:prstGeom>
+          <a:noFill/>
+          <a:ln/>
+        </p:spPr>
+        <p:txBody>
+          <a:bodyPr wrap="square" lIns="0" tIns="0" rIns="0" bIns="0" rtlCol="0" anchor="ctr">
+            <a:normAutofit/>
+          </a:bodyPr>
+          <a:lstStyle/>
+          <a:p>
+            <a:pPr marL="0" indent="0">
+              <a:buNone/>
+            </a:pPr>
+            <a:r>
+              <a:t>Sem novas evoluções nesta etapa, estas questões orientam os trabalhos futuros.</a:t>
+            </a:r>
+            <a:endParaRPr lang="en-US" sz="1400" dirty="0"/>
+          </a:p>
+        </p:txBody>
+      </p:sp>
+      <p:sp>
+        <p:nvSpPr>
+          <p:cNvPr id="8" name="Text 5"/>
+          <p:cNvSpPr/>
+          <p:nvPr/>
+        </p:nvSpPr>
+        <p:spPr>
+          <a:xfrm>
+            <a:off x="11292840" y="6446520"/>
+            <a:ext cx="502920" cy="164592"/>
+          </a:xfrm>
+          <a:prstGeom prst="rect">
+            <a:avLst/>
+          </a:prstGeom>
+          <a:noFill/>
+          <a:ln/>
+        </p:spPr>
+        <p:txBody>
+          <a:bodyPr wrap="square" lIns="0" tIns="0" rIns="0" bIns="0" rtlCol="0" anchor="ctr"/>
+          <a:lstStyle/>
+          <a:p>
+            <a:pPr marL="0" indent="0" algn="r">
+              <a:buNone/>
+            </a:pPr>
+            <a:r>
+              <a:rPr lang="en-US" sz="850" dirty="0">
+                <a:solidFill>
+                  <a:srgbClr val="5A5F6A"/>
+                </a:solidFill>
+              </a:rPr>
+              <a:t>10 / 12</a:t>
+            </a:r>
+            <a:endParaRPr lang="en-US" sz="850" dirty="0"/>
+          </a:p>
+        </p:txBody>
+      </p:sp>
+      <p:sp>
+        <p:nvSpPr>
+          <p:cNvPr id="9" name="Text 6"/>
+          <p:cNvSpPr/>
+          <p:nvPr/>
+        </p:nvSpPr>
+        <p:spPr>
+          <a:xfrm>
+            <a:off x="822960" y="2075688"/>
+            <a:ext cx="274320" cy="228600"/>
+          </a:xfrm>
+          <a:prstGeom prst="rect">
+            <a:avLst/>
+          </a:prstGeom>
+          <a:noFill/>
+          <a:ln/>
+        </p:spPr>
+        <p:txBody>
+          <a:bodyPr wrap="square" lIns="0" tIns="0" rIns="0" bIns="0" rtlCol="0" anchor="ctr"/>
+          <a:lstStyle/>
+          <a:p>
+            <a:pPr marL="0" indent="0">
+              <a:buNone/>
+            </a:pPr>
+            <a:r>
+              <a:rPr lang="en-US" sz="1400" b="1" dirty="0">
+                <a:solidFill>
+                  <a:srgbClr val="E52529"/>
+                </a:solidFill>
+              </a:rPr>
+              <a:t>1</a:t>
+            </a:r>
+            <a:endParaRPr lang="en-US" sz="1400" dirty="0"/>
+          </a:p>
+        </p:txBody>
+      </p:sp>
+      <p:sp>
+        <p:nvSpPr>
+          <p:cNvPr id="10" name="Text 7"/>
+          <p:cNvSpPr/>
+          <p:nvPr/>
+        </p:nvSpPr>
+        <p:spPr>
+          <a:xfrm>
+            <a:off x="1234440" y="2057400"/>
+            <a:ext cx="2057400" cy="228600"/>
+          </a:xfrm>
+          <a:prstGeom prst="rect">
+            <a:avLst/>
+          </a:prstGeom>
+          <a:noFill/>
+          <a:ln/>
+        </p:spPr>
+        <p:txBody>
+          <a:bodyPr wrap="square" lIns="0" tIns="0" rIns="0" bIns="0" rtlCol="0" anchor="ctr"/>
+          <a:lstStyle/>
+          <a:p>
+            <a:pPr marL="0" indent="0">
+              <a:buNone/>
+            </a:pPr>
+            <a:r>
+              <a:t>Efeito do onboarding</a:t>
+            </a:r>
+            <a:endParaRPr lang="en-US" sz="1500" dirty="0"/>
+          </a:p>
+        </p:txBody>
+      </p:sp>
+      <p:sp>
+        <p:nvSpPr>
+          <p:cNvPr id="11" name="Text 8"/>
+          <p:cNvSpPr/>
+          <p:nvPr/>
+        </p:nvSpPr>
+        <p:spPr>
+          <a:xfrm>
+            <a:off x="3520440" y="2084832"/>
+            <a:ext cx="4892040" cy="219456"/>
+          </a:xfrm>
+          <a:prstGeom prst="rect">
+            <a:avLst/>
+          </a:prstGeom>
+          <a:noFill/>
+          <a:ln/>
+        </p:spPr>
+        <p:txBody>
+          <a:bodyPr wrap="square" lIns="0" tIns="0" rIns="0" bIns="0" rtlCol="0" anchor="ctr">
+            <a:normAutofit/>
+          </a:bodyPr>
+          <a:lstStyle/>
+          <a:p>
+            <a:pPr marL="0" indent="0">
+              <a:buNone/>
+            </a:pPr>
+            <a:r>
+              <a:t>Medir a clareza nos mesmos usuários antes e depois, isolando a mudança de público.</a:t>
+            </a:r>
+            <a:endParaRPr lang="en-US" sz="1130" dirty="0"/>
+          </a:p>
+        </p:txBody>
+      </p:sp>
+      <p:sp>
+        <p:nvSpPr>
+          <p:cNvPr id="12" name="Text 9"/>
+          <p:cNvSpPr/>
+          <p:nvPr/>
+        </p:nvSpPr>
+        <p:spPr>
+          <a:xfrm>
+            <a:off x="8823960" y="2057400"/>
+            <a:ext cx="914400" cy="228600"/>
+          </a:xfrm>
+          <a:prstGeom prst="rect">
+            <a:avLst/>
+          </a:prstGeom>
+          <a:noFill/>
+          <a:ln/>
+        </p:spPr>
+        <p:txBody>
+          <a:bodyPr wrap="square" lIns="0" tIns="0" rIns="0" bIns="0" rtlCol="0" anchor="ctr"/>
+          <a:lstStyle/>
+          <a:p>
+            <a:pPr marL="0" indent="0" algn="ctr">
+              <a:buNone/>
+            </a:pPr>
+            <a:r>
+              <a:rPr lang="en-US" sz="1000" b="1" dirty="0">
+                <a:solidFill>
+                  <a:srgbClr val="E52529"/>
+                </a:solidFill>
+              </a:rPr>
+              <a:t>Causal</a:t>
+            </a:r>
+            <a:endParaRPr lang="en-US" sz="1000" dirty="0"/>
+          </a:p>
+        </p:txBody>
+      </p:sp>
+      <p:sp>
+        <p:nvSpPr>
+          <p:cNvPr id="13" name="Text 10"/>
+          <p:cNvSpPr/>
+          <p:nvPr/>
+        </p:nvSpPr>
+        <p:spPr>
+          <a:xfrm>
+            <a:off x="822960" y="2834640"/>
+            <a:ext cx="274320" cy="228600"/>
+          </a:xfrm>
+          <a:prstGeom prst="rect">
+            <a:avLst/>
+          </a:prstGeom>
+          <a:noFill/>
+          <a:ln/>
+        </p:spPr>
+        <p:txBody>
+          <a:bodyPr wrap="square" lIns="0" tIns="0" rIns="0" bIns="0" rtlCol="0" anchor="ctr"/>
+          <a:lstStyle/>
+          <a:p>
+            <a:pPr marL="0" indent="0">
+              <a:buNone/>
+            </a:pPr>
+            <a:r>
+              <a:rPr lang="en-US" sz="1400" b="1" dirty="0">
+                <a:solidFill>
+                  <a:srgbClr val="E52529"/>
+                </a:solidFill>
+              </a:rPr>
+              <a:t>2</a:t>
+            </a:r>
+            <a:endParaRPr lang="en-US" sz="1400" dirty="0"/>
+          </a:p>
+        </p:txBody>
+      </p:sp>
+      <p:sp>
+        <p:nvSpPr>
+          <p:cNvPr id="14" name="Text 11"/>
+          <p:cNvSpPr/>
+          <p:nvPr/>
+        </p:nvSpPr>
+        <p:spPr>
+          <a:xfrm>
+            <a:off x="1234440" y="2816352"/>
+            <a:ext cx="2057400" cy="228600"/>
+          </a:xfrm>
+          <a:prstGeom prst="rect">
+            <a:avLst/>
+          </a:prstGeom>
+          <a:noFill/>
+          <a:ln/>
+        </p:spPr>
+        <p:txBody>
+          <a:bodyPr wrap="square" lIns="0" tIns="0" rIns="0" bIns="0" rtlCol="0" anchor="ctr"/>
+          <a:lstStyle/>
+          <a:p>
+            <a:pPr marL="0" indent="0">
+              <a:buNone/>
+            </a:pPr>
+            <a:r>
+              <a:t>Navegação guiada</a:t>
+            </a:r>
+            <a:endParaRPr lang="en-US" sz="1500" dirty="0"/>
+          </a:p>
+        </p:txBody>
+      </p:sp>
+      <p:sp>
+        <p:nvSpPr>
+          <p:cNvPr id="15" name="Text 12"/>
+          <p:cNvSpPr/>
+          <p:nvPr/>
+        </p:nvSpPr>
+        <p:spPr>
+          <a:xfrm>
+            <a:off x="3520440" y="2843784"/>
+            <a:ext cx="4892040" cy="219456"/>
+          </a:xfrm>
+          <a:prstGeom prst="rect">
+            <a:avLst/>
+          </a:prstGeom>
+          <a:noFill/>
+          <a:ln/>
+        </p:spPr>
+        <p:txBody>
+          <a:bodyPr wrap="square" lIns="0" tIns="0" rIns="0" bIns="0" rtlCol="0" anchor="ctr">
+            <a:normAutofit/>
+          </a:bodyPr>
+          <a:lstStyle/>
+          <a:p>
+            <a:pPr marL="0" indent="0">
+              <a:buNone/>
+            </a:pPr>
+            <a:r>
+              <a:t>Verificar se menu, fluxo em etapas e exemplos elevam a clareza acima de 3,8.</a:t>
+            </a:r>
+            <a:endParaRPr lang="en-US" sz="1130" dirty="0"/>
+          </a:p>
+        </p:txBody>
+      </p:sp>
+      <p:sp>
+        <p:nvSpPr>
+          <p:cNvPr id="16" name="Text 13"/>
+          <p:cNvSpPr/>
+          <p:nvPr/>
+        </p:nvSpPr>
+        <p:spPr>
+          <a:xfrm>
+            <a:off x="8823960" y="2816352"/>
+            <a:ext cx="914400" cy="228600"/>
+          </a:xfrm>
+          <a:prstGeom prst="rect">
+            <a:avLst/>
+          </a:prstGeom>
+          <a:noFill/>
+          <a:ln/>
+        </p:spPr>
+        <p:txBody>
+          <a:bodyPr wrap="square" lIns="0" tIns="0" rIns="0" bIns="0" rtlCol="0" anchor="ctr"/>
+          <a:lstStyle/>
+          <a:p>
+            <a:pPr marL="0" indent="0" algn="ctr">
+              <a:buNone/>
+            </a:pPr>
+            <a:r>
+              <a:rPr lang="en-US" sz="1000" b="1" dirty="0">
+                <a:solidFill>
+                  <a:srgbClr val="E52529"/>
+                </a:solidFill>
+              </a:rPr>
+              <a:t>UX</a:t>
+            </a:r>
+            <a:endParaRPr lang="en-US" sz="1000" dirty="0"/>
+          </a:p>
+        </p:txBody>
+      </p:sp>
+      <p:sp>
+        <p:nvSpPr>
+          <p:cNvPr id="17" name="Text 14"/>
+          <p:cNvSpPr/>
+          <p:nvPr/>
+        </p:nvSpPr>
+        <p:spPr>
+          <a:xfrm>
+            <a:off x="822960" y="3593592"/>
+            <a:ext cx="274320" cy="228600"/>
+          </a:xfrm>
+          <a:prstGeom prst="rect">
+            <a:avLst/>
+          </a:prstGeom>
+          <a:noFill/>
+          <a:ln/>
+        </p:spPr>
+        <p:txBody>
+          <a:bodyPr wrap="square" lIns="0" tIns="0" rIns="0" bIns="0" rtlCol="0" anchor="ctr"/>
+          <a:lstStyle/>
+          <a:p>
+            <a:pPr marL="0" indent="0">
+              <a:buNone/>
+            </a:pPr>
+            <a:r>
+              <a:rPr lang="en-US" sz="1400" b="1" dirty="0">
+                <a:solidFill>
+                  <a:srgbClr val="E52529"/>
+                </a:solidFill>
+              </a:rPr>
+              <a:t>3</a:t>
+            </a:r>
+            <a:endParaRPr lang="en-US" sz="1400" dirty="0"/>
+          </a:p>
+        </p:txBody>
+      </p:sp>
+      <p:sp>
+        <p:nvSpPr>
+          <p:cNvPr id="18" name="Text 15"/>
+          <p:cNvSpPr/>
+          <p:nvPr/>
+        </p:nvSpPr>
+        <p:spPr>
+          <a:xfrm>
+            <a:off x="1234440" y="3575304"/>
+            <a:ext cx="2057400" cy="228600"/>
+          </a:xfrm>
+          <a:prstGeom prst="rect">
+            <a:avLst/>
+          </a:prstGeom>
+          <a:noFill/>
+          <a:ln/>
+        </p:spPr>
+        <p:txBody>
+          <a:bodyPr wrap="square" lIns="0" tIns="0" rIns="0" bIns="0" rtlCol="0" anchor="ctr"/>
+          <a:lstStyle/>
+          <a:p>
+            <a:pPr marL="0" indent="0">
+              <a:buNone/>
+            </a:pPr>
+            <a:r>
+              <a:t>Extração e qualidade</a:t>
+            </a:r>
+            <a:endParaRPr lang="en-US" sz="1500" dirty="0"/>
+          </a:p>
+        </p:txBody>
+      </p:sp>
+      <p:sp>
+        <p:nvSpPr>
+          <p:cNvPr id="19" name="Text 16"/>
+          <p:cNvSpPr/>
+          <p:nvPr/>
+        </p:nvSpPr>
+        <p:spPr>
+          <a:xfrm>
+            <a:off x="3520440" y="3602736"/>
+            <a:ext cx="4892040" cy="219456"/>
+          </a:xfrm>
+          <a:prstGeom prst="rect">
+            <a:avLst/>
+          </a:prstGeom>
+          <a:noFill/>
+          <a:ln/>
+        </p:spPr>
+        <p:txBody>
+          <a:bodyPr wrap="square" lIns="0" tIns="0" rIns="0" bIns="0" rtlCol="0" anchor="ctr">
+            <a:normAutofit/>
+          </a:bodyPr>
+          <a:lstStyle/>
+          <a:p>
+            <a:pPr marL="0" indent="0">
+              <a:buNone/>
+            </a:pPr>
+            <a:r>
+              <a:t>Executar o protocolo do MPO: acurácia da extração e efeito da IA na qualidade dos aprendizados.</a:t>
+            </a:r>
+            <a:endParaRPr lang="en-US" sz="1130" dirty="0"/>
+          </a:p>
+        </p:txBody>
+      </p:sp>
+      <p:sp>
+        <p:nvSpPr>
+          <p:cNvPr id="20" name="Text 17"/>
+          <p:cNvSpPr/>
+          <p:nvPr/>
+        </p:nvSpPr>
+        <p:spPr>
+          <a:xfrm>
+            <a:off x="8823960" y="3575304"/>
+            <a:ext cx="914400" cy="228600"/>
+          </a:xfrm>
+          <a:prstGeom prst="rect">
+            <a:avLst/>
+          </a:prstGeom>
+          <a:noFill/>
+          <a:ln/>
+        </p:spPr>
+        <p:txBody>
+          <a:bodyPr wrap="square" lIns="0" tIns="0" rIns="0" bIns="0" rtlCol="0" anchor="ctr"/>
+          <a:lstStyle/>
+          <a:p>
+            <a:pPr marL="0" indent="0" algn="ctr">
+              <a:buNone/>
+            </a:pPr>
+            <a:r>
+              <a:rPr lang="en-US" sz="1000" b="1" dirty="0">
+                <a:solidFill>
+                  <a:srgbClr val="1E3D6D"/>
+                </a:solidFill>
+              </a:rPr>
+              <a:t>MPO</a:t>
+            </a:r>
+            <a:endParaRPr lang="en-US" sz="1000" dirty="0"/>
+          </a:p>
+        </p:txBody>
+      </p:sp>
+      <p:sp>
+        <p:nvSpPr>
+          <p:cNvPr id="21" name="Text 18"/>
+          <p:cNvSpPr/>
+          <p:nvPr/>
+        </p:nvSpPr>
+        <p:spPr>
+          <a:xfrm>
+            <a:off x="822960" y="4352544"/>
+            <a:ext cx="274320" cy="228600"/>
+          </a:xfrm>
+          <a:prstGeom prst="rect">
+            <a:avLst/>
+          </a:prstGeom>
+          <a:noFill/>
+          <a:ln/>
+        </p:spPr>
+        <p:txBody>
+          <a:bodyPr wrap="square" lIns="0" tIns="0" rIns="0" bIns="0" rtlCol="0" anchor="ctr"/>
+          <a:lstStyle/>
+          <a:p>
+            <a:pPr marL="0" indent="0">
+              <a:buNone/>
+            </a:pPr>
+            <a:r>
+              <a:rPr lang="en-US" sz="1400" b="1" dirty="0">
+                <a:solidFill>
+                  <a:srgbClr val="E52529"/>
+                </a:solidFill>
+              </a:rPr>
+              <a:t>4</a:t>
+            </a:r>
+            <a:endParaRPr lang="en-US" sz="1400" dirty="0"/>
+          </a:p>
+        </p:txBody>
+      </p:sp>
+      <p:sp>
+        <p:nvSpPr>
+          <p:cNvPr id="22" name="Text 19"/>
+          <p:cNvSpPr/>
+          <p:nvPr/>
+        </p:nvSpPr>
+        <p:spPr>
+          <a:xfrm>
+            <a:off x="1234440" y="4334256"/>
+            <a:ext cx="2057400" cy="228600"/>
+          </a:xfrm>
+          <a:prstGeom prst="rect">
+            <a:avLst/>
+          </a:prstGeom>
+          <a:noFill/>
+          <a:ln/>
+        </p:spPr>
+        <p:txBody>
+          <a:bodyPr wrap="square" lIns="0" tIns="0" rIns="0" bIns="0" rtlCol="0" anchor="ctr"/>
+          <a:lstStyle/>
+          <a:p>
+            <a:pPr marL="0" indent="0">
+              <a:buNone/>
+            </a:pPr>
+            <a:r>
+              <a:t>Escala e governança</a:t>
+            </a:r>
+            <a:endParaRPr lang="en-US" sz="1500" dirty="0"/>
+          </a:p>
+        </p:txBody>
+      </p:sp>
+      <p:sp>
+        <p:nvSpPr>
+          <p:cNvPr id="23" name="Text 20"/>
+          <p:cNvSpPr/>
+          <p:nvPr/>
+        </p:nvSpPr>
+        <p:spPr>
+          <a:xfrm>
+            <a:off x="3520440" y="4361688"/>
+            <a:ext cx="4892040" cy="219456"/>
+          </a:xfrm>
+          <a:prstGeom prst="rect">
+            <a:avLst/>
+          </a:prstGeom>
+          <a:noFill/>
+          <a:ln/>
+        </p:spPr>
+        <p:txBody>
+          <a:bodyPr wrap="square" lIns="0" tIns="0" rIns="0" bIns="0" rtlCol="0" anchor="ctr">
+            <a:normAutofit/>
+          </a:bodyPr>
+          <a:lstStyle/>
+          <a:p>
+            <a:pPr marL="0" indent="0">
+              <a:buNone/>
+            </a:pPr>
+            <a:r>
+              <a:t>Replicar em outros domínios, com N maior e uso prolongado; entender a queda em governança.</a:t>
+            </a:r>
+            <a:endParaRPr lang="en-US" sz="1130" dirty="0"/>
+          </a:p>
+        </p:txBody>
+      </p:sp>
+      <p:sp>
+        <p:nvSpPr>
+          <p:cNvPr id="24" name="Text 21"/>
+          <p:cNvSpPr/>
+          <p:nvPr/>
+        </p:nvSpPr>
+        <p:spPr>
+          <a:xfrm>
+            <a:off x="8823960" y="4334256"/>
+            <a:ext cx="914400" cy="228600"/>
+          </a:xfrm>
+          <a:prstGeom prst="rect">
+            <a:avLst/>
+          </a:prstGeom>
+          <a:noFill/>
+          <a:ln/>
+        </p:spPr>
+        <p:txBody>
+          <a:bodyPr wrap="square" lIns="0" tIns="0" rIns="0" bIns="0" rtlCol="0" anchor="ctr"/>
+          <a:lstStyle/>
+          <a:p>
+            <a:pPr marL="0" indent="0" algn="ctr">
+              <a:buNone/>
+            </a:pPr>
+            <a:r>
+              <a:rPr lang="en-US" sz="1000" b="1" dirty="0">
+                <a:solidFill>
+                  <a:srgbClr val="1E3D6D"/>
+                </a:solidFill>
+              </a:rPr>
+              <a:t>Escala</a:t>
+            </a:r>
+            <a:endParaRPr lang="en-US" sz="1000" dirty="0"/>
+          </a:p>
+        </p:txBody>
+      </p:sp>
+      <p:sp>
+        <p:nvSpPr>
+          <p:cNvPr id="26" name="Text 22"/>
+          <p:cNvSpPr/>
+          <p:nvPr/>
+        </p:nvSpPr>
+        <p:spPr>
+          <a:xfrm>
+            <a:off x="1097280" y="5276088"/>
+            <a:ext cx="9090516" cy="384048"/>
+          </a:xfrm>
+          <a:prstGeom prst="rect">
+            <a:avLst/>
+          </a:prstGeom>
+          <a:noFill/>
+          <a:ln/>
+        </p:spPr>
+        <p:txBody>
+          <a:bodyPr wrap="square" lIns="0" tIns="0" rIns="0" bIns="0" rtlCol="0" anchor="ctr">
+            <a:normAutofit/>
+          </a:bodyPr>
+          <a:lstStyle/>
+          <a:p>
+            <a:pPr marL="0" indent="0">
+              <a:buNone/>
+            </a:pPr>
+            <a:r>
+              <a:t>As quatro frentes delimitam os gaps da pesquisa: o valor foi confirmado, mas restam questões de causalidade, experiência, extração e generalização.</a:t>
+            </a:r>
+            <a:endParaRPr lang="en-US" sz="1250" dirty="0"/>
+          </a:p>
+        </p:txBody>
+      </p:sp>
+      <p:pic>
+        <p:nvPicPr>
+          <p:cNvPr id="29" name="Picture 28" descr="image.png"/>
+          <p:cNvPicPr>
+            <a:picLocks noChangeAspect="1"/>
+          </p:cNvPicPr>
+          <p:nvPr/>
+        </p:nvPicPr>
+        <p:blipFill>
+          <a:blip r:embed="rId2"/>
+          <a:stretch>
+            <a:fillRect/>
+          </a:stretch>
+        </p:blipFill>
+        <p:spPr>
+          <a:xfrm>
+            <a:off x="10899648" y="329184"/>
+            <a:ext cx="804672" cy="594360"/>
+          </a:xfrm>
+          <a:prstGeom prst="rect">
+            <a:avLst/>
+          </a:prstGeom>
+        </p:spPr>
+      </p:pic>
     </p:spTree>
   </p:cSld>
   <p:clrMapOvr>
@@ -2620,6 +3513,10 @@
             <a:prstDash val="solid"/>
           </a:ln>
         </p:spPr>
+        <p:txBody>
+          <a:bodyPr/>
+          <a:p/>
+        </p:txBody>
       </p:sp>
       <p:pic>
         <p:nvPicPr>
@@ -2749,7 +3646,7 @@
                   <a:srgbClr val="5A5F6A"/>
                 </a:solidFill>
               </a:rPr>
-              <a:t>2 / 11</a:t>
+              <a:t>2 / 12</a:t>
             </a:r>
             <a:endParaRPr lang="en-US" sz="850" dirty="0"/>
           </a:p>
@@ -3279,6 +4176,10 @@
             <a:prstDash val="solid"/>
           </a:ln>
         </p:spPr>
+        <p:txBody>
+          <a:bodyPr/>
+          <a:p/>
+        </p:txBody>
       </p:sp>
       <p:pic>
         <p:nvPicPr>
@@ -3436,7 +4337,7 @@
                   <a:srgbClr val="5A5F6A"/>
                 </a:solidFill>
               </a:rPr>
-              <a:t>3 / 11</a:t>
+              <a:t>3 / 12</a:t>
             </a:r>
             <a:endParaRPr lang="en-US" sz="850" dirty="0"/>
           </a:p>
@@ -3466,6 +4367,10 @@
             <a:prstDash val="solid"/>
           </a:ln>
         </p:spPr>
+        <p:txBody>
+          <a:bodyPr/>
+          <a:p/>
+        </p:txBody>
       </p:sp>
       <p:sp>
         <p:nvSpPr>
@@ -3706,6 +4611,10 @@
             <a:prstDash val="solid"/>
           </a:ln>
         </p:spPr>
+        <p:txBody>
+          <a:bodyPr/>
+          <a:p/>
+        </p:txBody>
       </p:sp>
       <p:pic>
         <p:nvPicPr>
@@ -3868,7 +4777,7 @@
                   <a:srgbClr val="5A5F6A"/>
                 </a:solidFill>
               </a:rPr>
-              <a:t>4 / 11</a:t>
+              <a:t>4 / 12</a:t>
             </a:r>
             <a:endParaRPr lang="en-US" sz="850" dirty="0"/>
           </a:p>
@@ -3900,6 +4809,10 @@
             <a:prstDash val="solid"/>
           </a:ln>
         </p:spPr>
+        <p:txBody>
+          <a:bodyPr/>
+          <a:p/>
+        </p:txBody>
       </p:sp>
       <p:sp>
         <p:nvSpPr>
@@ -4031,6 +4944,10 @@
             <a:prstDash val="solid"/>
           </a:ln>
         </p:spPr>
+        <p:txBody>
+          <a:bodyPr/>
+          <a:p/>
+        </p:txBody>
       </p:sp>
       <p:sp>
         <p:nvSpPr>
@@ -4058,6 +4975,10 @@
             <a:prstDash val="solid"/>
           </a:ln>
         </p:spPr>
+        <p:txBody>
+          <a:bodyPr/>
+          <a:p/>
+        </p:txBody>
       </p:sp>
       <p:sp>
         <p:nvSpPr>
@@ -4189,6 +5110,10 @@
             <a:prstDash val="solid"/>
           </a:ln>
         </p:spPr>
+        <p:txBody>
+          <a:bodyPr/>
+          <a:p/>
+        </p:txBody>
       </p:sp>
       <p:sp>
         <p:nvSpPr>
@@ -4216,6 +5141,10 @@
             <a:prstDash val="solid"/>
           </a:ln>
         </p:spPr>
+        <p:txBody>
+          <a:bodyPr/>
+          <a:p/>
+        </p:txBody>
       </p:sp>
       <p:sp>
         <p:nvSpPr>
@@ -4347,6 +5276,10 @@
             <a:prstDash val="solid"/>
           </a:ln>
         </p:spPr>
+        <p:txBody>
+          <a:bodyPr/>
+          <a:p/>
+        </p:txBody>
       </p:sp>
       <p:sp>
         <p:nvSpPr>
@@ -4374,6 +5307,10 @@
             <a:prstDash val="solid"/>
           </a:ln>
         </p:spPr>
+        <p:txBody>
+          <a:bodyPr/>
+          <a:p/>
+        </p:txBody>
       </p:sp>
       <p:sp>
         <p:nvSpPr>
@@ -4606,6 +5543,10 @@
             <a:prstDash val="solid"/>
           </a:ln>
         </p:spPr>
+        <p:txBody>
+          <a:bodyPr/>
+          <a:p/>
+        </p:txBody>
       </p:sp>
       <p:pic>
         <p:nvPicPr>
@@ -4763,7 +5704,7 @@
                   <a:srgbClr val="5A5F6A"/>
                 </a:solidFill>
               </a:rPr>
-              <a:t>5 / 11</a:t>
+              <a:t>5 / 12</a:t>
             </a:r>
             <a:endParaRPr lang="en-US" sz="850" dirty="0"/>
           </a:p>
@@ -4795,6 +5736,10 @@
             <a:prstDash val="solid"/>
           </a:ln>
         </p:spPr>
+        <p:txBody>
+          <a:bodyPr/>
+          <a:p/>
+        </p:txBody>
       </p:sp>
       <p:sp>
         <p:nvSpPr>
@@ -4921,6 +5866,10 @@
             <a:prstDash val="solid"/>
           </a:ln>
         </p:spPr>
+        <p:txBody>
+          <a:bodyPr/>
+          <a:p/>
+        </p:txBody>
       </p:sp>
       <p:sp>
         <p:nvSpPr>
@@ -5047,6 +5996,10 @@
             <a:prstDash val="solid"/>
           </a:ln>
         </p:spPr>
+        <p:txBody>
+          <a:bodyPr/>
+          <a:p/>
+        </p:txBody>
       </p:sp>
       <p:sp>
         <p:nvSpPr>
@@ -5173,6 +6126,10 @@
             <a:prstDash val="solid"/>
           </a:ln>
         </p:spPr>
+        <p:txBody>
+          <a:bodyPr/>
+          <a:p/>
+        </p:txBody>
       </p:sp>
       <p:sp>
         <p:nvSpPr>
@@ -5297,6 +6254,10 @@
             <a:prstDash val="solid"/>
           </a:ln>
         </p:spPr>
+        <p:txBody>
+          <a:bodyPr/>
+          <a:p/>
+        </p:txBody>
       </p:sp>
       <p:sp>
         <p:nvSpPr>
@@ -5463,6 +6424,10 @@
             <a:prstDash val="solid"/>
           </a:ln>
         </p:spPr>
+        <p:txBody>
+          <a:bodyPr/>
+          <a:p/>
+        </p:txBody>
       </p:sp>
       <p:pic>
         <p:nvPicPr>
@@ -5620,7 +6585,7 @@
                   <a:srgbClr val="5A5F6A"/>
                 </a:solidFill>
               </a:rPr>
-              <a:t>6 / 11</a:t>
+              <a:t>6 / 12</a:t>
             </a:r>
             <a:endParaRPr lang="en-US" sz="850" dirty="0"/>
           </a:p>
@@ -5652,6 +6617,10 @@
             <a:prstDash val="solid"/>
           </a:ln>
         </p:spPr>
+        <p:txBody>
+          <a:bodyPr/>
+          <a:p/>
+        </p:txBody>
       </p:sp>
       <p:sp>
         <p:nvSpPr>
@@ -5778,6 +6747,10 @@
             <a:prstDash val="solid"/>
           </a:ln>
         </p:spPr>
+        <p:txBody>
+          <a:bodyPr/>
+          <a:p/>
+        </p:txBody>
       </p:sp>
       <p:sp>
         <p:nvSpPr>
@@ -5904,6 +6877,10 @@
             <a:prstDash val="solid"/>
           </a:ln>
         </p:spPr>
+        <p:txBody>
+          <a:bodyPr/>
+          <a:p/>
+        </p:txBody>
       </p:sp>
       <p:sp>
         <p:nvSpPr>
@@ -6030,6 +7007,10 @@
             <a:prstDash val="solid"/>
           </a:ln>
         </p:spPr>
+        <p:txBody>
+          <a:bodyPr/>
+          <a:p/>
+        </p:txBody>
       </p:sp>
       <p:sp>
         <p:nvSpPr>
@@ -6303,6 +7284,10 @@
             <a:prstDash val="solid"/>
           </a:ln>
         </p:spPr>
+        <p:txBody>
+          <a:bodyPr/>
+          <a:p/>
+        </p:txBody>
       </p:sp>
       <p:pic>
         <p:nvPicPr>
@@ -6466,7 +7451,7 @@
                   <a:srgbClr val="5A5F6A"/>
                 </a:solidFill>
               </a:rPr>
-              <a:t>7 / 11</a:t>
+              <a:t>7 / 12</a:t>
             </a:r>
             <a:endParaRPr lang="en-US" sz="850" dirty="0"/>
           </a:p>
@@ -7969,6 +8954,10 @@
             <a:prstDash val="solid"/>
           </a:ln>
         </p:spPr>
+        <p:txBody>
+          <a:bodyPr/>
+          <a:p/>
+        </p:txBody>
       </p:sp>
       <p:pic>
         <p:nvPicPr>
@@ -8126,7 +9115,7 @@
                   <a:srgbClr val="5A5F6A"/>
                 </a:solidFill>
               </a:rPr>
-              <a:t>8 / 11</a:t>
+              <a:t>8 / 12</a:t>
             </a:r>
             <a:endParaRPr lang="en-US" sz="850" dirty="0"/>
           </a:p>
@@ -8158,6 +9147,10 @@
             <a:prstDash val="solid"/>
           </a:ln>
         </p:spPr>
+        <p:txBody>
+          <a:bodyPr/>
+          <a:p/>
+        </p:txBody>
       </p:sp>
       <p:sp>
         <p:nvSpPr>
@@ -8282,6 +9275,10 @@
             <a:prstDash val="solid"/>
           </a:ln>
         </p:spPr>
+        <p:txBody>
+          <a:bodyPr/>
+          <a:p/>
+        </p:txBody>
       </p:sp>
       <p:sp>
         <p:nvSpPr>
@@ -8406,6 +9403,10 @@
             <a:prstDash val="solid"/>
           </a:ln>
         </p:spPr>
+        <p:txBody>
+          <a:bodyPr/>
+          <a:p/>
+        </p:txBody>
       </p:sp>
       <p:sp>
         <p:nvSpPr>
@@ -8530,6 +9531,10 @@
             <a:prstDash val="solid"/>
           </a:ln>
         </p:spPr>
+        <p:txBody>
+          <a:bodyPr/>
+          <a:p/>
+        </p:txBody>
       </p:sp>
       <p:sp>
         <p:nvSpPr>
@@ -8691,6 +9696,10 @@
             <a:prstDash val="solid"/>
           </a:ln>
         </p:spPr>
+        <p:txBody>
+          <a:bodyPr/>
+          <a:p/>
+        </p:txBody>
       </p:sp>
       <p:sp>
         <p:nvSpPr>
@@ -8755,6 +9764,10 @@
             <a:prstDash val="solid"/>
           </a:ln>
         </p:spPr>
+        <p:txBody>
+          <a:bodyPr/>
+          <a:p/>
+        </p:txBody>
       </p:sp>
       <p:pic>
         <p:nvPicPr>
@@ -8912,7 +9925,7 @@
                   <a:srgbClr val="5A5F6A"/>
                 </a:solidFill>
               </a:rPr>
-              <a:t>9 / 11</a:t>
+              <a:t>9 / 12</a:t>
             </a:r>
             <a:endParaRPr lang="en-US" sz="850" dirty="0"/>
           </a:p>

</xml_diff>